<commit_message>
feat: Implement shape gradient fill functionality and validation
- Added gradient fill model/API in `pkg/pptx`: `ShapeGradientFill` and `ShapeGradientStop`.
- Supported gradient types: `linear`, `radial`, `rectangular`, `path`.
- Introduced fluent API methods: `WithGradientFill(...)` and `WithLinearAngle(...)`.
- Implemented strict validation for shape gradients in `pkg/pptx/slide_drawings_validation.go`, ensuring at least two strictly-increasing stops and valid color/transparency values.
- Enhanced XML rendering in `internal/pptxxml` to emit gradient fill elements.
- Added integration tests for gradient fills in `pkg/pptx/shape_gradient_test.go`.
- Implemented automatic text color contrast selection based on shape fill in `pkg/pptx/shape_text_contrast_test.go`.
- Introduced connector auto-site functionality in `pkg/pptx`, allowing for automatic site selection based on shape positions.
- Updated showcase presentation to demonstrate new gradient fill and connector features.
</commit_message>
<xml_diff>
--- a/smoke_samples/goppt_feature_showcase.pptx
+++ b/smoke_samples/goppt_feature_showcase.pptx
@@ -13,6 +13,7 @@
     <p:sldId id="262" r:id="rId8"/>
     <p:sldId id="263" r:id="rId9"/>
     <p:sldId id="264" r:id="rId10"/>
+    <p:sldId id="265" r:id="rId11"/>
   </p:sldIdLst>
   <p:sldSz cx="9144000" cy="6858000" type="screen4x3"/>
   <p:notesSz cx="6858000" cy="9144000"/>
@@ -237,6 +238,81 @@
 </p:sldLayout>
 </file>
 
+<file path=ppt/slideLayouts/slideLayout4.xml><?xml version="1.0" encoding="utf-8"?>
+<p:sldLayout xmlns:a="http://schemas.openxmlformats.org/drawingml/2006/main" xmlns:r="http://schemas.openxmlformats.org/officeDocument/2006/relationships" xmlns:p="http://schemas.openxmlformats.org/presentationml/2006/main" type="title" preserve="1">
+  <p:cSld name="Centered Title">
+    <p:spTree>
+      <p:nvGrpSpPr>
+        <p:cNvPr id="1" name=""/>
+        <p:cNvGrpSpPr/>
+        <p:nvPr/>
+      </p:nvGrpSpPr>
+      <p:grpSpPr>
+        <a:xfrm>
+          <a:off x="0" y="0"/>
+          <a:ext cx="0" cy="0"/>
+          <a:chOff x="0" y="0"/>
+          <a:chExt cx="0" cy="0"/>
+        </a:xfrm>
+      </p:grpSpPr>
+    </p:spTree>
+  </p:cSld>
+  <p:clrMapOvr>
+    <a:masterClrMapping/>
+  </p:clrMapOvr>
+</p:sldLayout>
+</file>
+
+<file path=ppt/slideLayouts/slideLayout5.xml><?xml version="1.0" encoding="utf-8"?>
+<p:sldLayout xmlns:a="http://schemas.openxmlformats.org/drawingml/2006/main" xmlns:r="http://schemas.openxmlformats.org/officeDocument/2006/relationships" xmlns:p="http://schemas.openxmlformats.org/presentationml/2006/main" type="titleAndObj" preserve="1">
+  <p:cSld name="Title and Big Content">
+    <p:spTree>
+      <p:nvGrpSpPr>
+        <p:cNvPr id="1" name=""/>
+        <p:cNvGrpSpPr/>
+        <p:nvPr/>
+      </p:nvGrpSpPr>
+      <p:grpSpPr>
+        <a:xfrm>
+          <a:off x="0" y="0"/>
+          <a:ext cx="0" cy="0"/>
+          <a:chOff x="0" y="0"/>
+          <a:chExt cx="0" cy="0"/>
+        </a:xfrm>
+      </p:grpSpPr>
+    </p:spTree>
+  </p:cSld>
+  <p:clrMapOvr>
+    <a:masterClrMapping/>
+  </p:clrMapOvr>
+</p:sldLayout>
+</file>
+
+<file path=ppt/slideLayouts/slideLayout6.xml><?xml version="1.0" encoding="utf-8"?>
+<p:sldLayout xmlns:a="http://schemas.openxmlformats.org/drawingml/2006/main" xmlns:r="http://schemas.openxmlformats.org/officeDocument/2006/relationships" xmlns:p="http://schemas.openxmlformats.org/presentationml/2006/main" type="twoObj" preserve="1">
+  <p:cSld name="Two Column">
+    <p:spTree>
+      <p:nvGrpSpPr>
+        <p:cNvPr id="1" name=""/>
+        <p:cNvGrpSpPr/>
+        <p:nvPr/>
+      </p:nvGrpSpPr>
+      <p:grpSpPr>
+        <a:xfrm>
+          <a:off x="0" y="0"/>
+          <a:ext cx="0" cy="0"/>
+          <a:chOff x="0" y="0"/>
+          <a:chExt cx="0" cy="0"/>
+        </a:xfrm>
+      </p:grpSpPr>
+    </p:spTree>
+  </p:cSld>
+  <p:clrMapOvr>
+    <a:masterClrMapping/>
+  </p:clrMapOvr>
+</p:sldLayout>
+</file>
+
 <file path=ppt/slideMasters/slideMaster1.xml><?xml version="1.0" encoding="utf-8"?>
 <p:sldMaster xmlns:a="http://schemas.openxmlformats.org/drawingml/2006/main" xmlns:r="http://schemas.openxmlformats.org/officeDocument/2006/relationships" xmlns:p="http://schemas.openxmlformats.org/presentationml/2006/main">
   <p:cSld>
@@ -266,6 +342,9 @@
     <p:sldLayoutId id="2147483649" r:id="rId1"/>
     <p:sldLayoutId id="2147483650" r:id="rId2"/>
     <p:sldLayoutId id="2147483651" r:id="rId3"/>
+    <p:sldLayoutId id="2147483652" r:id="rId4"/>
+    <p:sldLayoutId id="2147483653" r:id="rId5"/>
+    <p:sldLayoutId id="2147483654" r:id="rId6"/>
   </p:sldLayoutIdLst>
 </p:sldMaster>
 </file>
@@ -373,6 +452,15 @@
             <a:r>
               <a:rPr lang="en-US" sz="2800" b="0" i="0" dirty="0"/>
               <a:t>Markdown inline rich text and text-run formatting</a:t>
+            </a:r>
+          </a:p>
+          <a:p>
+            <a:pPr lvl="0" marL="457200" indent="-457200">
+              <a:buChar char="•"/>
+            </a:pPr>
+            <a:r>
+              <a:rPr lang="en-US" sz="2800" b="0" i="0" dirty="0"/>
+              <a:t>Shapes/connectors with gradient fill rendering</a:t>
             </a:r>
           </a:p>
         </p:txBody>
@@ -829,6 +917,164 @@
       </p:grpSpPr>
       <p:sp>
         <p:nvSpPr>
+          <p:cNvPr id="2" name="Shape 2"/>
+          <p:cNvSpPr/>
+          <p:nvPr/>
+        </p:nvSpPr>
+        <p:spPr>
+          <a:xfrm>
+            <a:off x="822960" y="1645920"/>
+            <a:ext cx="2377440" cy="1005840"/>
+          </a:xfrm>
+          <a:prstGeom prst="roundRect">
+            <a:avLst/>
+          </a:prstGeom>
+          <a:solidFill>
+            <a:srgbClr val="D9E1F2"/>
+          </a:solidFill>
+          <a:ln w="19050">
+            <a:solidFill>
+              <a:srgbClr val="5B9BD5"/>
+            </a:solidFill>
+          </a:ln>
+        </p:spPr>
+        <p:txBody>
+          <a:bodyPr wrap="square" rtlCol="0" anchor="ctr">
+            <a:spAutoFit/>
+          </a:bodyPr>
+          <a:lstStyle/>
+          <a:p>
+            <a:pPr algn="ctr"/>
+            <a:r>
+              <a:rPr lang="en-US" sz="2500" b="0" i="0" u="none" dirty="0">
+                <a:solidFill>
+                  <a:srgbClr val="000000"/>
+                </a:solidFill>
+              </a:rPr>
+              <a:t>Input</a:t>
+            </a:r>
+          </a:p>
+        </p:txBody>
+      </p:sp>
+      <p:sp>
+        <p:nvSpPr>
+          <p:cNvPr id="3" name="Shape 3"/>
+          <p:cNvSpPr/>
+          <p:nvPr/>
+        </p:nvSpPr>
+        <p:spPr>
+          <a:xfrm>
+            <a:off x="3749040" y="1463040"/>
+            <a:ext cx="2560320" cy="1463040"/>
+          </a:xfrm>
+          <a:prstGeom prst="flowChartDecision">
+            <a:avLst/>
+          </a:prstGeom>
+          <a:gradFill rotWithShape="1">
+            <a:gsLst>
+              <a:gs pos="0">
+                <a:srgbClr val="4472C4"/>
+              </a:gs>
+              <a:gs pos="100000">
+                <a:srgbClr val="8FB9E0">
+                  <a:alpha val="80000"/>
+                </a:srgbClr>
+              </a:gs>
+            </a:gsLst>
+            <a:lin ang="2100000" scaled="1"/>
+          </a:gradFill>
+          <a:ln w="19050">
+            <a:solidFill>
+              <a:srgbClr val="1F4E78"/>
+            </a:solidFill>
+          </a:ln>
+        </p:spPr>
+        <p:txBody>
+          <a:bodyPr wrap="square" rtlCol="0" anchor="ctr">
+            <a:spAutoFit/>
+          </a:bodyPr>
+          <a:lstStyle/>
+          <a:p>
+            <a:pPr algn="ctr"/>
+            <a:r>
+              <a:rPr lang="en-US" sz="3600" b="0" i="0" u="none" dirty="0">
+                <a:solidFill>
+                  <a:srgbClr val="000000"/>
+                </a:solidFill>
+              </a:rPr>
+              <a:t>Validate</a:t>
+            </a:r>
+          </a:p>
+        </p:txBody>
+      </p:sp>
+      <p:cxnSp>
+        <p:nvCxnSpPr>
+          <p:cNvPr id="4" name="Connector 4"/>
+          <p:cNvCxnSpPr>
+            <a:stCxn id="2" idx="1"/>
+            <a:endCxn id="3" idx="3"/>
+          </p:cNvCxnSpPr>
+          <p:nvPr/>
+        </p:nvCxnSpPr>
+        <p:spPr>
+          <a:xfrm>
+            <a:off x="3200400" y="2148840"/>
+            <a:ext cx="548640" cy="0"/>
+          </a:xfrm>
+          <a:prstGeom prst="bentConnector3">
+            <a:avLst/>
+          </a:prstGeom>
+          <a:ln w="13970">
+            <a:solidFill>
+              <a:srgbClr val="1F4E78"/>
+            </a:solidFill>
+            <a:prstDash val="dashDot"/>
+            <a:tailEnd type="triangle" w="lg" len="lg"/>
+          </a:ln>
+        </p:spPr>
+        <p:txBody>
+          <a:bodyPr/>
+          <a:lstStyle/>
+          <a:p>
+            <a:r>
+              <a:rPr lang="en-US" sz="1000" b="0" i="0" u="none" dirty="0"/>
+              <a:t>next</a:t>
+            </a:r>
+          </a:p>
+        </p:txBody>
+      </p:cxnSp>
+    </p:spTree>
+  </p:cSld>
+  <p:clrMapOvr>
+    <a:masterClrMapping/>
+  </p:clrMapOvr>
+</p:sld>
+</file>
+
+<file path=ppt/slides/slide7.xml><?xml version="1.0" encoding="utf-8"?>
+<p:sld xmlns:a="http://schemas.openxmlformats.org/drawingml/2006/main" xmlns:c="http://schemas.openxmlformats.org/drawingml/2006/chart" xmlns:r="http://schemas.openxmlformats.org/officeDocument/2006/relationships" xmlns:p="http://schemas.openxmlformats.org/presentationml/2006/main">
+  <p:cSld>
+    <p:bg>
+      <p:bgRef idx="1001">
+        <a:schemeClr val="bg1"/>
+      </p:bgRef>
+    </p:bg>
+    <p:spTree>
+      <p:nvGrpSpPr>
+        <p:cNvPr id="1" name=""/>
+        <p:cNvGrpSpPr/>
+        <p:nvPr/>
+      </p:nvGrpSpPr>
+      <p:grpSpPr>
+        <a:xfrm>
+          <a:off x="0" y="0"/>
+          <a:ext cx="9144000" cy="6858000"/>
+          <a:chOff x="0" y="0"/>
+          <a:chExt cx="9144000" cy="6858000"/>
+        </a:xfrm>
+      </p:grpSpPr>
+      <p:sp>
+        <p:nvSpPr>
           <p:cNvPr id="2" name="Title"/>
           <p:cNvSpPr txBox="1"/>
           <p:nvPr/>
@@ -879,7 +1125,7 @@
 </p:sld>
 </file>
 
-<file path=ppt/slides/slide7.xml><?xml version="1.0" encoding="utf-8"?>
+<file path=ppt/slides/slide8.xml><?xml version="1.0" encoding="utf-8"?>
 <p:sld xmlns:a="http://schemas.openxmlformats.org/drawingml/2006/main" xmlns:c="http://schemas.openxmlformats.org/drawingml/2006/chart" xmlns:r="http://schemas.openxmlformats.org/officeDocument/2006/relationships" xmlns:p="http://schemas.openxmlformats.org/presentationml/2006/main">
   <p:cSld>
     <p:bg>
@@ -994,7 +1240,7 @@
 </p:sld>
 </file>
 
-<file path=ppt/slides/slide8.xml><?xml version="1.0" encoding="utf-8"?>
+<file path=ppt/slides/slide9.xml><?xml version="1.0" encoding="utf-8"?>
 <p:sld xmlns:a="http://schemas.openxmlformats.org/drawingml/2006/main" xmlns:c="http://schemas.openxmlformats.org/drawingml/2006/chart" xmlns:r="http://schemas.openxmlformats.org/officeDocument/2006/relationships" xmlns:p="http://schemas.openxmlformats.org/presentationml/2006/main">
   <p:cSld>
     <p:bg>
@@ -1065,7 +1311,7 @@
           <a:lstStyle/>
           <a:p>
             <a:pPr lvl="0" marL="457200" indent="-457200">
-              <a:buChar char="•"/>
+              <a:buAutoNum type="arabicPeriod"/>
             </a:pPr>
             <a:r>
               <a:rPr lang="en-US" sz="2800" b="0" i="0" dirty="0"/>
@@ -1074,7 +1320,7 @@
           </a:p>
           <a:p>
             <a:pPr lvl="0" marL="457200" indent="-457200">
-              <a:buChar char="•"/>
+              <a:buAutoNum type="arabicPeriod"/>
             </a:pPr>
             <a:r>
               <a:rPr lang="en-US" sz="2800" b="0" i="0" dirty="0"/>

</xml_diff>